<commit_message>
Entregável 2: logo vetorizado em alta resolução e versão em PDF
Co-Authored-By: Claude Fable 5.1 <noreply@anthropic.com>
Claude-Session: https://claude.ai/code/session_01JRCkHmicKHPzYQacrFg1xX
</commit_message>
<xml_diff>
--- a/Entregavel_2_Aula_10_Ri_Happy.pptx
+++ b/Entregavel_2_Aula_10_Ri_Happy.pptx
@@ -117,12 +117,12 @@
   <p:extLst>
     <p:ext uri="{521415D9-36F7-43E2-AB2F-B90AF26B5E84}">
       <p14:sectionLst xmlns:p14="http://schemas.microsoft.com/office/powerpoint/2010/main">
-        <p14:section name="Abertura" id="{0a4d218d-d52f-cc2a-e617-903f3f270f98}">
+        <p14:section name="Abertura" id="{ee9fb062-7d98-fecf-68a9-e0e03216be25}">
           <p14:sldIdLst>
             <p14:sldId id="256"/>
           </p14:sldIdLst>
         </p14:section>
-        <p14:section name="Diagnóstico" id="{c1bdd871-b5b7-317b-31c2-c6fd037882bd}">
+        <p14:section name="Diagnóstico" id="{2a7008a2-7d8f-421c-5ffd-af5a6d15608c}">
           <p14:sldIdLst>
             <p14:sldId id="257"/>
             <p14:sldId id="258"/>
@@ -130,7 +130,7 @@
             <p14:sldId id="260"/>
           </p14:sldIdLst>
         </p14:section>
-        <p14:section name="Proposta" id="{8044b49d-1659-c782-d1d4-8cb6e5b58f4c}">
+        <p14:section name="Proposta" id="{286afcf1-efd5-9420-8bed-e49612f90a8a}">
           <p14:sldIdLst>
             <p14:sldId id="261"/>
             <p14:sldId id="262"/>
@@ -138,7 +138,7 @@
             <p14:sldId id="264"/>
           </p14:sldIdLst>
         </p14:section>
-        <p14:section name="Conclusão" id="{48ab798c-9ae9-b586-80e6-1c0e26b23cae}">
+        <p14:section name="Conclusão" id="{6925a19d-c63a-953c-7749-52e4debb00ad}">
           <p14:sldIdLst>
             <p14:sldId id="265"/>
             <p14:sldId id="266"/>

</xml_diff>

<commit_message>
Entregável 2: corrige nomes das alunas na capa
Co-Authored-By: Claude Fable 5.1 <noreply@anthropic.com>
Claude-Session: https://claude.ai/code/session_01JRCkHmicKHPzYQacrFg1xX
</commit_message>
<xml_diff>
--- a/Entregavel_2_Aula_10_Ri_Happy.pptx
+++ b/Entregavel_2_Aula_10_Ri_Happy.pptx
@@ -117,12 +117,12 @@
   <p:extLst>
     <p:ext uri="{521415D9-36F7-43E2-AB2F-B90AF26B5E84}">
       <p14:sectionLst xmlns:p14="http://schemas.microsoft.com/office/powerpoint/2010/main">
-        <p14:section name="Abertura" id="{ee9fb062-7d98-fecf-68a9-e0e03216be25}">
+        <p14:section name="Abertura" id="{be3baacb-04c9-87ac-4894-3a08977d4e4e}">
           <p14:sldIdLst>
             <p14:sldId id="256"/>
           </p14:sldIdLst>
         </p14:section>
-        <p14:section name="Diagnóstico" id="{2a7008a2-7d8f-421c-5ffd-af5a6d15608c}">
+        <p14:section name="Diagnóstico" id="{05a54d2e-3c0a-f06e-1520-ae662c52d56d}">
           <p14:sldIdLst>
             <p14:sldId id="257"/>
             <p14:sldId id="258"/>
@@ -130,7 +130,7 @@
             <p14:sldId id="260"/>
           </p14:sldIdLst>
         </p14:section>
-        <p14:section name="Proposta" id="{286afcf1-efd5-9420-8bed-e49612f90a8a}">
+        <p14:section name="Proposta" id="{1801e9b3-48fd-017a-337c-5bbca5b9d21b}">
           <p14:sldIdLst>
             <p14:sldId id="261"/>
             <p14:sldId id="262"/>
@@ -138,7 +138,7 @@
             <p14:sldId id="264"/>
           </p14:sldIdLst>
         </p14:section>
-        <p14:section name="Conclusão" id="{6925a19d-c63a-953c-7749-52e4debb00ad}">
+        <p14:section name="Conclusão" id="{ace67e5d-96b1-eca7-9229-62143b7bc6da}">
           <p14:sldIdLst>
             <p14:sldId id="265"/>
             <p14:sldId id="266"/>
@@ -2648,7 +2648,7 @@
                   <a:schemeClr val="bg1"/>
                 </a:solidFill>
               </a:rPr>
-              <a:t>Alunas: Maria Luiza Morelli  |  Luisa Façanha  |  Ligia Silva  |  Anna Leticia Carvalho  |  Aymee Mendes</a:t>
+              <a:t>Alunas: Luísa Façanha  |  Maria Luiza Morelli  |  Aymêe Mendes  |  Lígia Silva  |  Anna Letícia Carvalho</a:t>
             </a:r>
             <a:endParaRPr lang="en-US" sz="1600" dirty="0"/>
           </a:p>

</xml_diff>